<commit_message>
Lezione 3: spiegata l'uscita del server verso internet sulla 443
</commit_message>
<xml_diff>
--- a/slide/slide-3-firewall.pptx
+++ b/slide/slide-3-firewall.pptx
@@ -1493,7 +1493,7 @@
           <a:p>
             <a:r>
               <a:rPr lang="en-US" dirty="0"/>
-              <a:t>Nelle prossime lezioni avremo un server dell'applicazione nelle subnet private, un database nelle subnet database e delle persone collegate da casa con la VPN. Le route table permettono già a tutte le subnet di parlarsi. Ma non vogliamo che chiunque nella rete possa raggiungere il database. Le regole che vogliamo sono queste: il server parla con il database, l'amministratore in VPN anche, nessun altro. Un firewall è proprio questo: un insieme di regole su cosa può passare.</a:t>
+              <a:t>Nelle prossime lezioni avremo un server dell'applicazione nelle subnet private, un database nelle subnet database e delle persone collegate da casa con la VPN. Le route table permettono già a tutte le subnet di parlarsi. Ma non vogliamo che chiunque nella rete possa raggiungere il database. Le regole che vogliamo sono queste: il server parla con il database, l'amministratore in VPN anche, nessun altro. Il server può anche chiamare internet sulla 443, solo in uscita: per scaricare gli aggiornamenti di sicurezza e per parlare con i servizi AWS, come SSM, S3 e Secrets Manager, che vedremo nelle prossime lezioni. Nessuno da internet può chiamare lui. Un firewall è proprio questo: un insieme di regole su cosa può passare.</a:t>
             </a:r>
             <a:endParaRPr lang="en-US" dirty="0"/>
           </a:p>
@@ -14975,7 +14975,7 @@
                           <a:ea typeface="Calibri" pitchFamily="34" charset="-122"/>
                           <a:cs typeface="Calibri" pitchFamily="34" charset="-120"/>
                         </a:rPr>
-                        <a:t>internet, porta 443 (aggiornamenti)</a:t>
+                        <a:t>internet, 443: SOLO in uscita (aggiornamenti, servizi AWS)</a:t>
                       </a:r>
                       <a:endParaRPr lang="en-US" sz="1700" dirty="0">
                         <a:latin typeface="Calibri" charset="0"/>

</xml_diff>